<commit_message>
ajout du moteur de finance
</commit_message>
<xml_diff>
--- a/business-model/GBANDI WAKE_Plateforme_Entree_Sortie_06-03-2026.pptx
+++ b/business-model/GBANDI WAKE_Plateforme_Entree_Sortie_06-03-2026.pptx
@@ -17179,7 +17179,7 @@
                           <a:ea typeface="Calibri" panose="020F0502020204030204" pitchFamily="34" charset="0"/>
                           <a:cs typeface="Arial" panose="020B0604020202020204" pitchFamily="34" charset="0"/>
                         </a:rPr>
-                        <a:t>08/05/2026</a:t>
+                        <a:t>22/05/2026</a:t>
                       </a:r>
                       <a:endParaRPr lang="fr-FR" sz="1800" b="1" kern="100" dirty="0">
                         <a:solidFill>
@@ -17332,6 +17332,18 @@
                         <a:buNone/>
                         <a:defRPr/>
                       </a:pPr>
+                      <a:r>
+                        <a:rPr lang="fr-FR" sz="1800" b="1" kern="100" noProof="0" dirty="0">
+                          <a:solidFill>
+                            <a:srgbClr val="F99D32"/>
+                          </a:solidFill>
+                          <a:effectLst/>
+                          <a:latin typeface="Arial Narrow" panose="020B0606020202030204" pitchFamily="34" charset="0"/>
+                          <a:ea typeface="Calibri" panose="020F0502020204030204" pitchFamily="34" charset="0"/>
+                          <a:cs typeface="Arial" panose="020B0604020202020204" pitchFamily="34" charset="0"/>
+                        </a:rPr>
+                        <a:t>MESSAN Jean-claude</a:t>
+                      </a:r>
                       <a:endParaRPr lang="fr-FR" sz="1800" b="1" kern="100" noProof="0" dirty="0">
                         <a:solidFill>
                           <a:srgbClr val="F99D32"/>
@@ -17554,6 +17566,19 @@
                           <a:spcPts val="800"/>
                         </a:spcAft>
                       </a:pPr>
+                      <a:r>
+                        <a:rPr lang="fr-FR" sz="1800" b="1" kern="100" noProof="0" dirty="0">
+                          <a:solidFill>
+                            <a:srgbClr val="F99D32"/>
+                          </a:solidFill>
+                          <a:effectLst/>
+                          <a:latin typeface="Arial Narrow" panose="020B0606020202030204" pitchFamily="34" charset="0"/>
+                          <a:ea typeface="Calibri" panose="020F0502020204030204" pitchFamily="34" charset="0"/>
+                          <a:cs typeface="Arial" panose="020B0604020202020204" pitchFamily="34" charset="0"/>
+                          <a:sym typeface="+mn-ea"/>
+                        </a:rPr>
+                        <a:t>MESSAN Jean-claude</a:t>
+                      </a:r>
                       <a:endParaRPr lang="fr-FR" sz="1800" b="1" kern="100" dirty="0">
                         <a:solidFill>
                           <a:srgbClr val="F99D32"/>
@@ -18020,7 +18045,7 @@
                 <a:cs typeface="Arial" panose="020B0604020202020204" pitchFamily="34" charset="0"/>
                 <a:sym typeface="+mn-ea"/>
               </a:rPr>
-              <a:t>08/05/2026</a:t>
+              <a:t>22/05/2026</a:t>
             </a:r>
             <a:endParaRPr lang="fr-FR" kern="100" dirty="0">
               <a:solidFill>
@@ -18660,7 +18685,7 @@
                 <a:cs typeface="Arial" panose="020B0604020202020204" pitchFamily="34" charset="0"/>
                 <a:sym typeface="+mn-ea"/>
               </a:rPr>
-              <a:t>08/05/2026</a:t>
+              <a:t>22/05/2026</a:t>
             </a:r>
             <a:endParaRPr lang="fr-FR"/>
           </a:p>

</xml_diff>